<commit_message>
bump default font sizes across decks and posters
Talks are read from across the room, not over the speaker's shoulder.
Body text now defaults to 30pt on slides (was 20) with titles/subtitles
scaled proportionally. A0 posters scale up to match — body 36pt, title
120pt — so the sheet still reads from across an aisle. Applied
identically to all four palettes (Sage Mist, Dusty Rose, Faded Indigo,
Deep Plum) and to both deck and poster layouts; preview screenshots
regenerated.

Co-Authored-By: Claude Opus 4 <noreply@anthropic.com>
</commit_message>
<xml_diff>
--- a/templates/deep_plum/KCLNLP_DeepPlum.pptx
+++ b/templates/deep_plum/KCLNLP_DeepPlum.pptx
@@ -3163,7 +3163,7 @@
           <a:p>
             <a:pPr algn="l"/>
             <a:r>
-              <a:rPr sz="4400" b="1" i="0">
+              <a:rPr sz="6000" b="1" i="0">
                 <a:solidFill>
                   <a:srgbClr val="2A2530"/>
                 </a:solidFill>
@@ -3198,7 +3198,7 @@
           <a:p>
             <a:pPr algn="l"/>
             <a:r>
-              <a:rPr sz="2200" b="0" i="1">
+              <a:rPr sz="3200" b="0" i="1">
                 <a:solidFill>
                   <a:srgbClr val="75707A"/>
                 </a:solidFill>
@@ -3276,7 +3276,7 @@
           <a:p>
             <a:pPr algn="l"/>
             <a:r>
-              <a:rPr sz="1600" b="0" i="0">
+              <a:rPr sz="2200" b="0" i="0">
                 <a:solidFill>
                   <a:srgbClr val="2A2530"/>
                 </a:solidFill>
@@ -3383,7 +3383,7 @@
           <a:p>
             <a:pPr algn="l"/>
             <a:r>
-              <a:rPr sz="1400" b="0" i="1">
+              <a:rPr sz="2000" b="0" i="1">
                 <a:solidFill>
                   <a:srgbClr val="75707A"/>
                 </a:solidFill>
@@ -3522,7 +3522,7 @@
           <a:p>
             <a:pPr algn="ctr"/>
             <a:r>
-              <a:rPr sz="4400" b="1" i="0">
+              <a:rPr sz="6000" b="1" i="0">
                 <a:solidFill>
                   <a:srgbClr val="2A2530"/>
                 </a:solidFill>
@@ -3557,7 +3557,7 @@
           <a:p>
             <a:pPr algn="ctr"/>
             <a:r>
-              <a:rPr sz="2200" b="0" i="1">
+              <a:rPr sz="3200" b="0" i="1">
                 <a:solidFill>
                   <a:srgbClr val="75707A"/>
                 </a:solidFill>
@@ -3592,7 +3592,7 @@
           <a:p>
             <a:pPr algn="ctr"/>
             <a:r>
-              <a:rPr sz="1600" b="0" i="0">
+              <a:rPr sz="2200" b="0" i="0">
                 <a:solidFill>
                   <a:srgbClr val="2A2530"/>
                 </a:solidFill>
@@ -3699,7 +3699,7 @@
           <a:p>
             <a:pPr algn="l"/>
             <a:r>
-              <a:rPr sz="1400" b="0" i="1">
+              <a:rPr sz="2000" b="0" i="1">
                 <a:solidFill>
                   <a:srgbClr val="75707A"/>
                 </a:solidFill>
@@ -3795,7 +3795,7 @@
           <a:p>
             <a:pPr algn="l"/>
             <a:r>
-              <a:rPr sz="7200" b="1" i="0">
+              <a:rPr sz="9600" b="1" i="0">
                 <a:solidFill>
                   <a:srgbClr val="6F5C7A"/>
                 </a:solidFill>
@@ -3865,7 +3865,7 @@
           <a:p>
             <a:pPr algn="l"/>
             <a:r>
-              <a:rPr sz="3600" b="1" i="0">
+              <a:rPr sz="4800" b="1" i="0">
                 <a:solidFill>
                   <a:srgbClr val="2A2530"/>
                 </a:solidFill>
@@ -3900,7 +3900,7 @@
           <a:p>
             <a:pPr algn="l"/>
             <a:r>
-              <a:rPr sz="1800" b="0" i="1">
+              <a:rPr sz="2400" b="0" i="1">
                 <a:solidFill>
                   <a:srgbClr val="75707A"/>
                 </a:solidFill>
@@ -4007,7 +4007,7 @@
           <a:p>
             <a:pPr algn="l"/>
             <a:r>
-              <a:rPr sz="1400" b="0" i="1">
+              <a:rPr sz="2000" b="0" i="1">
                 <a:solidFill>
                   <a:srgbClr val="75707A"/>
                 </a:solidFill>
@@ -4103,7 +4103,7 @@
           <a:p>
             <a:pPr algn="l"/>
             <a:r>
-              <a:rPr sz="2600" b="1" i="0">
+              <a:rPr sz="4000" b="1" i="0">
                 <a:solidFill>
                   <a:srgbClr val="2A2530"/>
                 </a:solidFill>
@@ -4185,7 +4185,7 @@
               </a:spcAft>
             </a:pPr>
             <a:r>
-              <a:rPr sz="2000">
+              <a:rPr sz="3000">
                 <a:solidFill>
                   <a:srgbClr val="2A2530"/>
                 </a:solidFill>
@@ -4201,7 +4201,7 @@
               </a:spcAft>
             </a:pPr>
             <a:r>
-              <a:rPr sz="2000">
+              <a:rPr sz="3000">
                 <a:solidFill>
                   <a:srgbClr val="2A2530"/>
                 </a:solidFill>
@@ -4217,7 +4217,7 @@
               </a:spcAft>
             </a:pPr>
             <a:r>
-              <a:rPr sz="2000">
+              <a:rPr sz="3000">
                 <a:solidFill>
                   <a:srgbClr val="2A2530"/>
                 </a:solidFill>
@@ -4233,7 +4233,7 @@
               </a:spcAft>
             </a:pPr>
             <a:r>
-              <a:rPr sz="2000">
+              <a:rPr sz="3000">
                 <a:solidFill>
                   <a:srgbClr val="2A2530"/>
                 </a:solidFill>
@@ -4249,7 +4249,7 @@
               </a:spcAft>
             </a:pPr>
             <a:r>
-              <a:rPr sz="2000">
+              <a:rPr sz="3000">
                 <a:solidFill>
                   <a:srgbClr val="2A2530"/>
                 </a:solidFill>
@@ -4356,7 +4356,7 @@
           <a:p>
             <a:pPr algn="l"/>
             <a:r>
-              <a:rPr sz="1400" b="0" i="1">
+              <a:rPr sz="2000" b="0" i="1">
                 <a:solidFill>
                   <a:srgbClr val="75707A"/>
                 </a:solidFill>
@@ -4452,7 +4452,7 @@
           <a:p>
             <a:pPr algn="l"/>
             <a:r>
-              <a:rPr sz="2600" b="1" i="0">
+              <a:rPr sz="4000" b="1" i="0">
                 <a:solidFill>
                   <a:srgbClr val="2A2530"/>
                 </a:solidFill>
@@ -4534,7 +4534,7 @@
               </a:spcAft>
             </a:pPr>
             <a:r>
-              <a:rPr sz="2000">
+              <a:rPr sz="3000">
                 <a:solidFill>
                   <a:srgbClr val="2A2530"/>
                 </a:solidFill>
@@ -4550,7 +4550,7 @@
               </a:spcAft>
             </a:pPr>
             <a:r>
-              <a:rPr sz="2000">
+              <a:rPr sz="3000">
                 <a:solidFill>
                   <a:srgbClr val="2A2530"/>
                 </a:solidFill>
@@ -4566,7 +4566,7 @@
               </a:spcAft>
             </a:pPr>
             <a:r>
-              <a:rPr sz="2000">
+              <a:rPr sz="3000">
                 <a:solidFill>
                   <a:srgbClr val="2A2530"/>
                 </a:solidFill>
@@ -4687,7 +4687,7 @@
           <a:p>
             <a:pPr algn="l"/>
             <a:r>
-              <a:rPr sz="1100" b="1" i="0">
+              <a:rPr sz="1600" b="1" i="0">
                 <a:solidFill>
                   <a:srgbClr val="6F5C7A"/>
                 </a:solidFill>
@@ -4722,7 +4722,7 @@
           <a:p>
             <a:pPr algn="l"/>
             <a:r>
-              <a:rPr sz="1800" b="0" i="0">
+              <a:rPr sz="2400" b="0" i="0">
                 <a:solidFill>
                   <a:srgbClr val="2A2530"/>
                 </a:solidFill>
@@ -4829,7 +4829,7 @@
           <a:p>
             <a:pPr algn="l"/>
             <a:r>
-              <a:rPr sz="1400" b="0" i="1">
+              <a:rPr sz="2000" b="0" i="1">
                 <a:solidFill>
                   <a:srgbClr val="75707A"/>
                 </a:solidFill>
@@ -4925,7 +4925,7 @@
           <a:p>
             <a:pPr algn="l"/>
             <a:r>
-              <a:rPr sz="2600" b="1" i="0">
+              <a:rPr sz="4000" b="1" i="0">
                 <a:solidFill>
                   <a:srgbClr val="2A2530"/>
                 </a:solidFill>
@@ -5003,7 +5003,7 @@
           <a:p>
             <a:pPr algn="l"/>
             <a:r>
-              <a:rPr sz="2800" b="1" i="0">
+              <a:rPr sz="4000" b="1" i="0">
                 <a:solidFill>
                   <a:srgbClr val="6F5C7A"/>
                 </a:solidFill>
@@ -5038,7 +5038,7 @@
           <a:p>
             <a:pPr algn="l"/>
             <a:r>
-              <a:rPr sz="2000" b="0" i="0">
+              <a:rPr sz="3000" b="0" i="0">
                 <a:solidFill>
                   <a:srgbClr val="2A2530"/>
                 </a:solidFill>
@@ -5108,7 +5108,7 @@
           <a:p>
             <a:pPr algn="l"/>
             <a:r>
-              <a:rPr sz="2800" b="1" i="0">
+              <a:rPr sz="4000" b="1" i="0">
                 <a:solidFill>
                   <a:srgbClr val="6F5C7A"/>
                 </a:solidFill>
@@ -5143,7 +5143,7 @@
           <a:p>
             <a:pPr algn="l"/>
             <a:r>
-              <a:rPr sz="2000" b="0" i="0">
+              <a:rPr sz="3000" b="0" i="0">
                 <a:solidFill>
                   <a:srgbClr val="2A2530"/>
                 </a:solidFill>
@@ -5213,7 +5213,7 @@
           <a:p>
             <a:pPr algn="l"/>
             <a:r>
-              <a:rPr sz="2800" b="1" i="0">
+              <a:rPr sz="4000" b="1" i="0">
                 <a:solidFill>
                   <a:srgbClr val="6F5C7A"/>
                 </a:solidFill>
@@ -5248,7 +5248,7 @@
           <a:p>
             <a:pPr algn="l"/>
             <a:r>
-              <a:rPr sz="2000" b="0" i="0">
+              <a:rPr sz="3000" b="0" i="0">
                 <a:solidFill>
                   <a:srgbClr val="2A2530"/>
                 </a:solidFill>
@@ -5390,7 +5390,7 @@
           <a:p>
             <a:pPr algn="l"/>
             <a:r>
-              <a:rPr sz="1400" b="0" i="1">
+              <a:rPr sz="2000" b="0" i="1">
                 <a:solidFill>
                   <a:srgbClr val="75707A"/>
                 </a:solidFill>
@@ -5486,7 +5486,7 @@
           <a:p>
             <a:pPr algn="l"/>
             <a:r>
-              <a:rPr sz="2600" b="1" i="0">
+              <a:rPr sz="4000" b="1" i="0">
                 <a:solidFill>
                   <a:srgbClr val="2A2530"/>
                 </a:solidFill>
@@ -5607,7 +5607,7 @@
           <a:p>
             <a:pPr algn="ctr"/>
             <a:r>
-              <a:rPr sz="1800" b="0" i="1">
+              <a:rPr sz="2400" b="0" i="1">
                 <a:solidFill>
                   <a:srgbClr val="75707A"/>
                 </a:solidFill>
@@ -5642,7 +5642,7 @@
           <a:p>
             <a:pPr algn="l"/>
             <a:r>
-              <a:rPr sz="2200" b="1" i="0">
+              <a:rPr sz="3000" b="1" i="0">
                 <a:solidFill>
                   <a:srgbClr val="2A2530"/>
                 </a:solidFill>
@@ -5681,7 +5681,7 @@
               </a:spcAft>
             </a:pPr>
             <a:r>
-              <a:rPr sz="1800">
+              <a:rPr sz="2800">
                 <a:solidFill>
                   <a:srgbClr val="2A2530"/>
                 </a:solidFill>
@@ -5697,7 +5697,7 @@
               </a:spcAft>
             </a:pPr>
             <a:r>
-              <a:rPr sz="1800">
+              <a:rPr sz="2800">
                 <a:solidFill>
                   <a:srgbClr val="2A2530"/>
                 </a:solidFill>
@@ -5713,7 +5713,7 @@
               </a:spcAft>
             </a:pPr>
             <a:r>
-              <a:rPr sz="1800">
+              <a:rPr sz="2800">
                 <a:solidFill>
                   <a:srgbClr val="2A2530"/>
                 </a:solidFill>
@@ -5820,7 +5820,7 @@
           <a:p>
             <a:pPr algn="l"/>
             <a:r>
-              <a:rPr sz="1400" b="0" i="1">
+              <a:rPr sz="2000" b="0" i="1">
                 <a:solidFill>
                   <a:srgbClr val="75707A"/>
                 </a:solidFill>
@@ -5916,7 +5916,7 @@
           <a:p>
             <a:pPr algn="l"/>
             <a:r>
-              <a:rPr sz="12000" b="1" i="0">
+              <a:rPr sz="16000" b="1" i="0">
                 <a:solidFill>
                   <a:srgbClr val="B4A0B8"/>
                 </a:solidFill>
@@ -5951,7 +5951,7 @@
           <a:p>
             <a:pPr algn="l"/>
             <a:r>
-              <a:rPr sz="3600" b="0" i="1">
+              <a:rPr sz="4800" b="0" i="1">
                 <a:solidFill>
                   <a:srgbClr val="2A2530"/>
                 </a:solidFill>
@@ -6029,7 +6029,7 @@
           <a:p>
             <a:pPr algn="l"/>
             <a:r>
-              <a:rPr sz="1100" b="1" i="0">
+              <a:rPr sz="1600" b="1" i="0">
                 <a:solidFill>
                   <a:srgbClr val="6F5C7A"/>
                 </a:solidFill>
@@ -6136,7 +6136,7 @@
           <a:p>
             <a:pPr algn="l"/>
             <a:r>
-              <a:rPr sz="1400" b="0" i="1">
+              <a:rPr sz="2000" b="0" i="1">
                 <a:solidFill>
                   <a:srgbClr val="75707A"/>
                 </a:solidFill>
@@ -6275,7 +6275,7 @@
           <a:p>
             <a:pPr algn="ctr"/>
             <a:r>
-              <a:rPr sz="5600" b="1" i="0">
+              <a:rPr sz="7200" b="1" i="0">
                 <a:solidFill>
                   <a:srgbClr val="2A2530"/>
                 </a:solidFill>
@@ -6310,7 +6310,7 @@
           <a:p>
             <a:pPr algn="ctr"/>
             <a:r>
-              <a:rPr sz="2200" b="0" i="1">
+              <a:rPr sz="3200" b="0" i="1">
                 <a:solidFill>
                   <a:srgbClr val="75707A"/>
                 </a:solidFill>
@@ -6345,7 +6345,7 @@
           <a:p>
             <a:pPr algn="ctr"/>
             <a:r>
-              <a:rPr sz="1600" b="0" i="0">
+              <a:rPr sz="2200" b="0" i="0">
                 <a:solidFill>
                   <a:srgbClr val="2A2530"/>
                 </a:solidFill>
@@ -6452,7 +6452,7 @@
           <a:p>
             <a:pPr algn="l"/>
             <a:r>
-              <a:rPr sz="1400" b="0" i="1">
+              <a:rPr sz="2000" b="0" i="1">
                 <a:solidFill>
                   <a:srgbClr val="75707A"/>
                 </a:solidFill>

</xml_diff>